<commit_message>
fix: typo in presentation
</commit_message>
<xml_diff>
--- a/2026_Б_ККП_ПЗПІ-23-1_Тітаренко_М_С/2026_Б_ККП_ПЗПІ-23-1_Тітаренко_М_С.pptx
+++ b/2026_Б_ККП_ПЗПІ-23-1_Тітаренко_М_С/2026_Б_ККП_ПЗПІ-23-1_Тітаренко_М_С.pptx
@@ -208,7 +208,7 @@
           <a:p>
             <a:fld id="{7C0E86BE-4F3A-4D9E-B99A-B861765272E0}" type="datetimeFigureOut">
               <a:rPr lang="uk-UA" smtClean="0"/>
-              <a:t>10.05.2026</a:t>
+              <a:t>16.05.2026</a:t>
             </a:fld>
             <a:endParaRPr lang="uk-UA"/>
           </a:p>
@@ -631,7 +631,7 @@
             <a:fld id="{90348686-127C-4120-B616-4289040A7004}" type="datetime1">
               <a:rPr lang="uk-UA" smtClean="0"/>
               <a:pPr/>
-              <a:t>10.05.2026</a:t>
+              <a:t>16.05.2026</a:t>
             </a:fld>
             <a:endParaRPr lang="uk-UA"/>
           </a:p>
@@ -846,7 +846,7 @@
           <a:p>
             <a:fld id="{8A5E2E62-B2D6-445C-97A7-4E362A639F85}" type="datetime1">
               <a:rPr lang="uk-UA" smtClean="0"/>
-              <a:t>10.05.2026</a:t>
+              <a:t>16.05.2026</a:t>
             </a:fld>
             <a:endParaRPr lang="uk-UA"/>
           </a:p>
@@ -1054,7 +1054,7 @@
           <a:p>
             <a:fld id="{088131B2-0C14-4D6A-B416-AEFA39167D01}" type="datetime1">
               <a:rPr lang="uk-UA" smtClean="0"/>
-              <a:t>10.05.2026</a:t>
+              <a:t>16.05.2026</a:t>
             </a:fld>
             <a:endParaRPr lang="uk-UA"/>
           </a:p>
@@ -1252,7 +1252,7 @@
           <a:p>
             <a:fld id="{EAF0E85B-4845-4781-865F-5550AB148711}" type="datetime1">
               <a:rPr lang="uk-UA" smtClean="0"/>
-              <a:t>10.05.2026</a:t>
+              <a:t>16.05.2026</a:t>
             </a:fld>
             <a:endParaRPr lang="uk-UA"/>
           </a:p>
@@ -1527,7 +1527,7 @@
           <a:p>
             <a:fld id="{CF79F800-79AF-4D29-8061-B44F112B4F16}" type="datetime1">
               <a:rPr lang="uk-UA" smtClean="0"/>
-              <a:t>10.05.2026</a:t>
+              <a:t>16.05.2026</a:t>
             </a:fld>
             <a:endParaRPr lang="uk-UA"/>
           </a:p>
@@ -1792,7 +1792,7 @@
           <a:p>
             <a:fld id="{833F35E6-0E1E-43D0-9122-A10F0C3C76F0}" type="datetime1">
               <a:rPr lang="uk-UA" smtClean="0"/>
-              <a:t>10.05.2026</a:t>
+              <a:t>16.05.2026</a:t>
             </a:fld>
             <a:endParaRPr lang="uk-UA"/>
           </a:p>
@@ -2204,7 +2204,7 @@
           <a:p>
             <a:fld id="{2ADC24B8-F4D3-47BA-8462-D930645CC0D3}" type="datetime1">
               <a:rPr lang="uk-UA" smtClean="0"/>
-              <a:t>10.05.2026</a:t>
+              <a:t>16.05.2026</a:t>
             </a:fld>
             <a:endParaRPr lang="uk-UA"/>
           </a:p>
@@ -2345,7 +2345,7 @@
           <a:p>
             <a:fld id="{7CF2D6B8-6BD3-4E74-ADB0-D69C04FF6FCE}" type="datetime1">
               <a:rPr lang="uk-UA" smtClean="0"/>
-              <a:t>10.05.2026</a:t>
+              <a:t>16.05.2026</a:t>
             </a:fld>
             <a:endParaRPr lang="uk-UA"/>
           </a:p>
@@ -2458,7 +2458,7 @@
           <a:p>
             <a:fld id="{0740A61B-1D10-4C78-B082-8FC64DB93002}" type="datetime1">
               <a:rPr lang="uk-UA" smtClean="0"/>
-              <a:t>10.05.2026</a:t>
+              <a:t>16.05.2026</a:t>
             </a:fld>
             <a:endParaRPr lang="uk-UA"/>
           </a:p>
@@ -2769,7 +2769,7 @@
           <a:p>
             <a:fld id="{C8540211-4A3E-4809-B89D-7BC3F90112BC}" type="datetime1">
               <a:rPr lang="uk-UA" smtClean="0"/>
-              <a:t>10.05.2026</a:t>
+              <a:t>16.05.2026</a:t>
             </a:fld>
             <a:endParaRPr lang="uk-UA"/>
           </a:p>
@@ -3057,7 +3057,7 @@
           <a:p>
             <a:fld id="{8A697D8A-AA77-4F03-936A-A3FB0932A535}" type="datetime1">
               <a:rPr lang="uk-UA" smtClean="0"/>
-              <a:t>10.05.2026</a:t>
+              <a:t>16.05.2026</a:t>
             </a:fld>
             <a:endParaRPr lang="uk-UA"/>
           </a:p>
@@ -3298,7 +3298,7 @@
           <a:p>
             <a:fld id="{925D61AF-8FD6-4C0B-AB26-C005D1C08023}" type="datetime1">
               <a:rPr lang="uk-UA" smtClean="0"/>
-              <a:t>10.05.2026</a:t>
+              <a:t>16.05.2026</a:t>
             </a:fld>
             <a:endParaRPr lang="uk-UA"/>
           </a:p>
@@ -4413,8 +4413,12 @@
               <a:t> </a:t>
             </a:r>
             <a:r>
-              <a:rPr lang="en-US" sz="3200" b="1" dirty="0" err="1"/>
-              <a:t>jwtToken</a:t>
+              <a:rPr lang="en-US" sz="3200" b="1" dirty="0"/>
+              <a:t>JWT-</a:t>
+            </a:r>
+            <a:r>
+              <a:rPr lang="uk-UA" sz="3200" b="1" dirty="0"/>
+              <a:t>токену</a:t>
             </a:r>
             <a:r>
               <a:rPr lang="en-US" sz="3200" b="1" dirty="0"/>
@@ -6234,7 +6238,7 @@
           <p:nvPr>
             <p:extLst>
               <p:ext uri="{D42A27DB-BD31-4B8C-83A1-F6EECF244321}">
-                <p14:modId xmlns:p14="http://schemas.microsoft.com/office/powerpoint/2010/main" val="1382757459"/>
+                <p14:modId xmlns:p14="http://schemas.microsoft.com/office/powerpoint/2010/main" val="1608587994"/>
               </p:ext>
             </p:extLst>
           </p:nvPr>
@@ -6434,7 +6438,7 @@
                       </a:r>
                       <a:r>
                         <a:rPr lang="uk-UA" sz="1400" dirty="0"/>
-                        <a:t>-орієнтовану архітектура (</a:t>
+                        <a:t>-орієнтована архітектура (</a:t>
                       </a:r>
                       <a:r>
                         <a:rPr lang="en-US" sz="1400" dirty="0"/>

</xml_diff>